<commit_message>
refactor: remove all emojis across UI components, localization, and documentation
</commit_message>
<xml_diff>
--- a/docs/PantryPal-AI-Presentation.pptx
+++ b/docs/PantryPal-AI-Presentation.pptx
@@ -4230,15 +4230,15 @@
               </a:defRPr>
             </a:pPr>
             <a:r>
-              <a:t>🔗 GitHub Repository: https://github.com/panchaksharayya12/PantryPal-AI</a:t>
+              <a:t>GitHub Repository: https://github.com/panchaksharayya12/PantryPal-AI</a:t>
             </a:r>
             <a:br/>
             <a:r>
-              <a:t>🌐 Live App: Deployed on Vercel</a:t>
+              <a:t>Live App: Deployed on Vercel</a:t>
             </a:r>
             <a:br/>
             <a:r>
-              <a:t>📄 Documentation &amp; Presentation: Included in repository /docs</a:t>
+              <a:t>Documentation &amp; Presentation: Included in repository /docs</a:t>
             </a:r>
           </a:p>
         </p:txBody>

</xml_diff>